<commit_message>
docs: updated session slides
</commit_message>
<xml_diff>
--- a/docs/CDC2026_Okutucu_MCP-Azure-Functions.pptx
+++ b/docs/CDC2026_Okutucu_MCP-Azure-Functions.pptx
@@ -19612,8 +19612,8 @@
         </p:nvSpPr>
         <p:spPr>
           <a:xfrm>
-            <a:off x="457200" y="1325880"/>
-            <a:ext cx="2423160" cy="2011680"/>
+            <a:off x="457200" y="2029968"/>
+            <a:ext cx="2423160" cy="2103120"/>
           </a:xfrm>
           <a:prstGeom prst="roundRect">
             <a:avLst>
@@ -19650,80 +19650,13 @@
       </p:sp>
       <p:sp>
         <p:nvSpPr>
-          <p:cNvPr id="9" name="TextBox 8"/>
-          <p:cNvSpPr txBox="1"/>
-          <p:nvPr/>
-        </p:nvSpPr>
-        <p:spPr>
-          <a:xfrm>
-            <a:off x="621792" y="1472184"/>
-            <a:ext cx="2093976" cy="1719072"/>
-          </a:xfrm>
-          <a:prstGeom prst="rect">
-            <a:avLst/>
-          </a:prstGeom>
-          <a:noFill/>
-        </p:spPr>
-        <p:txBody>
-          <a:bodyPr wrap="square" anchor="t" lIns="0" rIns="0" tIns="0" bIns="0">
-            <a:spAutoFit/>
-          </a:bodyPr>
-          <a:lstStyle/>
-          <a:p>
-            <a:pPr algn="l">
-              <a:spcAft>
-                <a:spcPts val="200"/>
-              </a:spcAft>
-            </a:pPr>
-            <a:r>
-              <a:rPr sz="900" b="1">
-                <a:solidFill>
-                  <a:srgbClr val="F5B08A"/>
-                </a:solidFill>
-                <a:latin typeface="Segoe UI"/>
-              </a:rPr>
-              <a:t>HOST</a:t>
-            </a:r>
-          </a:p>
-          <a:p>
-            <a:pPr algn="l">
-              <a:spcAft>
-                <a:spcPts val="400"/>
-              </a:spcAft>
-            </a:pPr>
-            <a:r>
-              <a:rPr sz="1500" b="1">
-                <a:solidFill>
-                  <a:srgbClr val="FFFFFF"/>
-                </a:solidFill>
-                <a:latin typeface="Segoe UI"/>
-              </a:rPr>
-              <a:t>The app with the model</a:t>
-            </a:r>
-          </a:p>
-          <a:p>
-            <a:pPr algn="l"/>
-            <a:r>
-              <a:rPr sz="1150" b="0">
-                <a:solidFill>
-                  <a:srgbClr val="C9CDD6"/>
-                </a:solidFill>
-                <a:latin typeface="Segoe UI"/>
-              </a:rPr>
-              <a:t>VS Code &amp; Copilot, Claude, M365 Copilot, Foundry agents, your own app</a:t>
-            </a:r>
-          </a:p>
-        </p:txBody>
-      </p:sp>
-      <p:sp>
-        <p:nvSpPr>
           <p:cNvPr id="10" name="Right Arrow 9"/>
           <p:cNvSpPr/>
           <p:nvPr/>
         </p:nvSpPr>
         <p:spPr>
           <a:xfrm>
-            <a:off x="2944368" y="2194560"/>
+            <a:off x="2944368" y="2926080"/>
             <a:ext cx="411480" cy="292608"/>
           </a:xfrm>
           <a:prstGeom prst="rightArrow">
@@ -19767,8 +19700,8 @@
         </p:nvSpPr>
         <p:spPr>
           <a:xfrm>
-            <a:off x="3383280" y="1325880"/>
-            <a:ext cx="2423160" cy="2011680"/>
+            <a:off x="3383280" y="2029968"/>
+            <a:ext cx="2423160" cy="2103120"/>
           </a:xfrm>
           <a:prstGeom prst="roundRect">
             <a:avLst>
@@ -19807,80 +19740,13 @@
       </p:sp>
       <p:sp>
         <p:nvSpPr>
-          <p:cNvPr id="12" name="TextBox 11"/>
-          <p:cNvSpPr txBox="1"/>
-          <p:nvPr/>
-        </p:nvSpPr>
-        <p:spPr>
-          <a:xfrm>
-            <a:off x="3547872" y="1472184"/>
-            <a:ext cx="2093976" cy="1719072"/>
-          </a:xfrm>
-          <a:prstGeom prst="rect">
-            <a:avLst/>
-          </a:prstGeom>
-          <a:noFill/>
-        </p:spPr>
-        <p:txBody>
-          <a:bodyPr wrap="square" anchor="t" lIns="0" rIns="0" tIns="0" bIns="0">
-            <a:spAutoFit/>
-          </a:bodyPr>
-          <a:lstStyle/>
-          <a:p>
-            <a:pPr algn="l">
-              <a:spcAft>
-                <a:spcPts val="200"/>
-              </a:spcAft>
-            </a:pPr>
-            <a:r>
-              <a:rPr sz="900" b="1">
-                <a:solidFill>
-                  <a:srgbClr val="E1571E"/>
-                </a:solidFill>
-                <a:latin typeface="Segoe UI"/>
-              </a:rPr>
-              <a:t>CLIENT</a:t>
-            </a:r>
-          </a:p>
-          <a:p>
-            <a:pPr algn="l">
-              <a:spcAft>
-                <a:spcPts val="400"/>
-              </a:spcAft>
-            </a:pPr>
-            <a:r>
-              <a:rPr sz="1500" b="1">
-                <a:solidFill>
-                  <a:srgbClr val="23262E"/>
-                </a:solidFill>
-                <a:latin typeface="Segoe UI"/>
-              </a:rPr>
-              <a:t>One per server</a:t>
-            </a:r>
-          </a:p>
-          <a:p>
-            <a:pPr algn="l"/>
-            <a:r>
-              <a:rPr sz="1150" b="0">
-                <a:solidFill>
-                  <a:srgbClr val="6F7682"/>
-                </a:solidFill>
-                <a:latin typeface="Segoe UI"/>
-              </a:rPr>
-              <a:t>Speaks the protocol: JSON-RPC over stdio or Streamable HTTP</a:t>
-            </a:r>
-          </a:p>
-        </p:txBody>
-      </p:sp>
-      <p:sp>
-        <p:nvSpPr>
           <p:cNvPr id="13" name="Right Arrow 12"/>
           <p:cNvSpPr/>
           <p:nvPr/>
         </p:nvSpPr>
         <p:spPr>
           <a:xfrm>
-            <a:off x="5870448" y="2194560"/>
+            <a:off x="5870448" y="2926080"/>
             <a:ext cx="411480" cy="292608"/>
           </a:xfrm>
           <a:prstGeom prst="rightArrow">
@@ -19924,8 +19790,8 @@
         </p:nvSpPr>
         <p:spPr>
           <a:xfrm>
-            <a:off x="6309360" y="1325880"/>
-            <a:ext cx="2423160" cy="2011680"/>
+            <a:off x="6309360" y="2029968"/>
+            <a:ext cx="2423160" cy="2103120"/>
           </a:xfrm>
           <a:prstGeom prst="roundRect">
             <a:avLst>
@@ -19962,14 +19828,62 @@
       </p:sp>
       <p:sp>
         <p:nvSpPr>
-          <p:cNvPr id="15" name="TextBox 14"/>
+          <p:cNvPr id="15" name="Rounded Rectangle 14"/>
+          <p:cNvSpPr/>
+          <p:nvPr/>
+        </p:nvSpPr>
+        <p:spPr>
+          <a:xfrm>
+            <a:off x="457200" y="1097280"/>
+            <a:ext cx="5166360" cy="804672"/>
+          </a:xfrm>
+          <a:prstGeom prst="roundRect">
+            <a:avLst>
+              <a:gd name="adj" fmla="val 6000"/>
+            </a:avLst>
+          </a:prstGeom>
+          <a:solidFill>
+            <a:srgbClr val="FAF7F4"/>
+          </a:solidFill>
+          <a:ln w="9525">
+            <a:solidFill>
+              <a:srgbClr val="E9E7E4"/>
+            </a:solidFill>
+          </a:ln>
+          <a:effectLst/>
+        </p:spPr>
+        <p:style>
+          <a:lnRef idx="1">
+            <a:schemeClr val="accent1"/>
+          </a:lnRef>
+          <a:fillRef idx="3">
+            <a:schemeClr val="accent1"/>
+          </a:fillRef>
+          <a:effectRef idx="2">
+            <a:schemeClr val="accent1"/>
+          </a:effectRef>
+          <a:fontRef idx="minor">
+            <a:schemeClr val="lt1"/>
+          </a:fontRef>
+        </p:style>
+        <p:txBody>
+          <a:bodyPr rtlCol="0" anchor="ctr"/>
+          <a:lstStyle/>
+          <a:p>
+            <a:pPr algn="ctr"/>
+          </a:p>
+        </p:txBody>
+      </p:sp>
+      <p:sp>
+        <p:nvSpPr>
+          <p:cNvPr id="16" name="TextBox 15"/>
           <p:cNvSpPr txBox="1"/>
           <p:nvPr/>
         </p:nvSpPr>
         <p:spPr>
           <a:xfrm>
-            <a:off x="6473952" y="1472184"/>
-            <a:ext cx="2093976" cy="1719072"/>
+            <a:off x="621792" y="1170432"/>
+            <a:ext cx="4846320" cy="685800"/>
           </a:xfrm>
           <a:prstGeom prst="rect">
             <a:avLst/>
@@ -19977,12 +19891,12 @@
           <a:noFill/>
         </p:spPr>
         <p:txBody>
-          <a:bodyPr wrap="square" anchor="t" lIns="0" rIns="0" tIns="0" bIns="0">
+          <a:bodyPr wrap="square" lIns="0" rIns="0" tIns="0" bIns="0" anchor="t">
             <a:spAutoFit/>
           </a:bodyPr>
           <a:lstStyle/>
           <a:p>
-            <a:pPr algn="l">
+            <a:pPr>
               <a:spcAft>
                 <a:spcPts val="200"/>
               </a:spcAft>
@@ -19990,53 +19904,336 @@
             <a:r>
               <a:rPr sz="900" b="1">
                 <a:solidFill>
-                  <a:srgbClr val="FBE9DF"/>
+                  <a:srgbClr val="E1571E"/>
                 </a:solidFill>
                 <a:latin typeface="Segoe UI"/>
               </a:rPr>
-              <a:t>SERVER</a:t>
-            </a:r>
-          </a:p>
-          <a:p>
-            <a:pPr algn="l">
+              <a:t>WHAT IS MCP?</a:t>
+            </a:r>
+          </a:p>
+          <a:p>
+            <a:pPr>
+              <a:spcAft>
+                <a:spcPts val="0"/>
+              </a:spcAft>
+            </a:pPr>
+            <a:r>
+              <a:rPr sz="1050" b="0">
+                <a:solidFill>
+                  <a:srgbClr val="23262E"/>
+                </a:solidFill>
+                <a:latin typeface="Segoe UI"/>
+              </a:rPr>
+              <a:t>The Model Context Protocol: an open standard that lets any AI app discover tools, call them and read data. Think USB-C for agents: build a server once, plug it into every MCP app.</a:t>
+            </a:r>
+          </a:p>
+        </p:txBody>
+      </p:sp>
+      <p:sp>
+        <p:nvSpPr>
+          <p:cNvPr id="17" name="Rounded Rectangle 16"/>
+          <p:cNvSpPr/>
+          <p:nvPr/>
+        </p:nvSpPr>
+        <p:spPr>
+          <a:xfrm>
+            <a:off x="5760720" y="1097280"/>
+            <a:ext cx="2971800" cy="804672"/>
+          </a:xfrm>
+          <a:prstGeom prst="roundRect">
+            <a:avLst>
+              <a:gd name="adj" fmla="val 6000"/>
+            </a:avLst>
+          </a:prstGeom>
+          <a:solidFill>
+            <a:srgbClr val="FBE9DF"/>
+          </a:solidFill>
+          <a:ln>
+            <a:noFill/>
+          </a:ln>
+          <a:effectLst/>
+        </p:spPr>
+        <p:style>
+          <a:lnRef idx="1">
+            <a:schemeClr val="accent1"/>
+          </a:lnRef>
+          <a:fillRef idx="3">
+            <a:schemeClr val="accent1"/>
+          </a:fillRef>
+          <a:effectRef idx="2">
+            <a:schemeClr val="accent1"/>
+          </a:effectRef>
+          <a:fontRef idx="minor">
+            <a:schemeClr val="lt1"/>
+          </a:fontRef>
+        </p:style>
+        <p:txBody>
+          <a:bodyPr rtlCol="0" anchor="ctr"/>
+          <a:lstStyle/>
+          <a:p>
+            <a:pPr algn="ctr"/>
+          </a:p>
+        </p:txBody>
+      </p:sp>
+      <p:sp>
+        <p:nvSpPr>
+          <p:cNvPr id="18" name="TextBox 17"/>
+          <p:cNvSpPr txBox="1"/>
+          <p:nvPr/>
+        </p:nvSpPr>
+        <p:spPr>
+          <a:xfrm>
+            <a:off x="5897880" y="1170432"/>
+            <a:ext cx="2788920" cy="685800"/>
+          </a:xfrm>
+          <a:prstGeom prst="rect">
+            <a:avLst/>
+          </a:prstGeom>
+          <a:noFill/>
+        </p:spPr>
+        <p:txBody>
+          <a:bodyPr wrap="square" lIns="0" rIns="0" tIns="0" bIns="0" anchor="t">
+            <a:spAutoFit/>
+          </a:bodyPr>
+          <a:lstStyle/>
+          <a:p>
+            <a:pPr>
+              <a:spcAft>
+                <a:spcPts val="200"/>
+              </a:spcAft>
+            </a:pPr>
+            <a:r>
+              <a:rPr sz="950" b="1">
+                <a:solidFill>
+                  <a:srgbClr val="E1571E"/>
+                </a:solidFill>
+                <a:latin typeface="Segoe UI"/>
+              </a:rPr>
+              <a:t>Nov 2024  </a:t>
+            </a:r>
+            <a:r>
+              <a:rPr sz="950" b="0">
+                <a:solidFill>
+                  <a:srgbClr val="23262E"/>
+                </a:solidFill>
+                <a:latin typeface="Segoe UI"/>
+              </a:rPr>
+              <a:t>open-sourced by Anthropic</a:t>
+            </a:r>
+          </a:p>
+          <a:p>
+            <a:pPr>
+              <a:spcAft>
+                <a:spcPts val="200"/>
+              </a:spcAft>
+            </a:pPr>
+            <a:r>
+              <a:rPr sz="950" b="1">
+                <a:solidFill>
+                  <a:srgbClr val="E1571E"/>
+                </a:solidFill>
+                <a:latin typeface="Segoe UI"/>
+              </a:rPr>
+              <a:t>2025  </a:t>
+            </a:r>
+            <a:r>
+              <a:rPr sz="950" b="0">
+                <a:solidFill>
+                  <a:srgbClr val="23262E"/>
+                </a:solidFill>
+                <a:latin typeface="Segoe UI"/>
+              </a:rPr>
+              <a:t>OpenAI, Google, Microsoft adopt it</a:t>
+            </a:r>
+          </a:p>
+          <a:p>
+            <a:pPr>
+              <a:spcAft>
+                <a:spcPts val="0"/>
+              </a:spcAft>
+            </a:pPr>
+            <a:r>
+              <a:rPr sz="950" b="1">
+                <a:solidFill>
+                  <a:srgbClr val="E1571E"/>
+                </a:solidFill>
+                <a:latin typeface="Segoe UI"/>
+              </a:rPr>
+              <a:t>Dec 2025  </a:t>
+            </a:r>
+            <a:r>
+              <a:rPr sz="950" b="0">
+                <a:solidFill>
+                  <a:srgbClr val="23262E"/>
+                </a:solidFill>
+                <a:latin typeface="Segoe UI"/>
+              </a:rPr>
+              <a:t>donated to the Linux Foundation</a:t>
+            </a:r>
+          </a:p>
+        </p:txBody>
+      </p:sp>
+      <p:sp>
+        <p:nvSpPr>
+          <p:cNvPr id="19" name="TextBox 18"/>
+          <p:cNvSpPr txBox="1"/>
+          <p:nvPr/>
+        </p:nvSpPr>
+        <p:spPr>
+          <a:xfrm>
+            <a:off x="612648" y="2139696"/>
+            <a:ext cx="2103120" cy="1920240"/>
+          </a:xfrm>
+          <a:prstGeom prst="rect">
+            <a:avLst/>
+          </a:prstGeom>
+          <a:noFill/>
+        </p:spPr>
+        <p:txBody>
+          <a:bodyPr wrap="square" lIns="0" rIns="0" tIns="0" bIns="0" anchor="t">
+            <a:spAutoFit/>
+          </a:bodyPr>
+          <a:lstStyle/>
+          <a:p>
+            <a:pPr>
+              <a:spcAft>
+                <a:spcPts val="200"/>
+              </a:spcAft>
+            </a:pPr>
+            <a:r>
+              <a:rPr sz="900" b="1">
+                <a:solidFill>
+                  <a:srgbClr val="F5B08A"/>
+                </a:solidFill>
+                <a:latin typeface="Segoe UI"/>
+              </a:rPr>
+              <a:t>HOST</a:t>
+            </a:r>
+          </a:p>
+          <a:p>
+            <a:pPr>
               <a:spcAft>
                 <a:spcPts val="400"/>
               </a:spcAft>
             </a:pPr>
             <a:r>
-              <a:rPr sz="1500" b="1">
+              <a:rPr sz="1300" b="1">
                 <a:solidFill>
                   <a:srgbClr val="FFFFFF"/>
                 </a:solidFill>
                 <a:latin typeface="Segoe UI"/>
               </a:rPr>
-              <a:t>Your code, today</a:t>
-            </a:r>
-          </a:p>
-          <a:p>
-            <a:pPr algn="l"/>
-            <a:r>
-              <a:rPr sz="1150" b="0">
-                <a:solidFill>
-                  <a:srgbClr val="FBE9DF"/>
+              <a:t>The app you talk to</a:t>
+            </a:r>
+          </a:p>
+          <a:p>
+            <a:pPr>
+              <a:spcAft>
+                <a:spcPts val="700"/>
+              </a:spcAft>
+            </a:pPr>
+            <a:r>
+              <a:rPr sz="950" b="0">
+                <a:solidFill>
+                  <a:srgbClr val="FFFFFF"/>
                 </a:solidFill>
                 <a:latin typeface="Segoe UI"/>
               </a:rPr>
-              <a:t>Tools (verbs) · Resources (nouns) · Prompts (templates) · MCP Apps (UI)</a:t>
-            </a:r>
-          </a:p>
-        </p:txBody>
-      </p:sp>
-      <p:sp>
-        <p:nvSpPr>
-          <p:cNvPr id="16" name="TextBox 15"/>
+              <a:t>Runs the model, owns the chat and asks for your consent.</a:t>
+            </a:r>
+          </a:p>
+          <a:p>
+            <a:pPr>
+              <a:spcAft>
+                <a:spcPts val="200"/>
+              </a:spcAft>
+            </a:pPr>
+            <a:r>
+              <a:rPr sz="850" b="1">
+                <a:solidFill>
+                  <a:srgbClr val="F5B08A"/>
+                </a:solidFill>
+                <a:latin typeface="Segoe UI"/>
+              </a:rPr>
+              <a:t>FOR EXAMPLE</a:t>
+            </a:r>
+          </a:p>
+          <a:p>
+            <a:pPr>
+              <a:spcAft>
+                <a:spcPts val="100"/>
+              </a:spcAft>
+            </a:pPr>
+            <a:r>
+              <a:rPr sz="950" b="1">
+                <a:solidFill>
+                  <a:srgbClr val="FFFFFF"/>
+                </a:solidFill>
+                <a:latin typeface="Segoe UI"/>
+              </a:rPr>
+              <a:t>· VS Code</a:t>
+            </a:r>
+          </a:p>
+          <a:p>
+            <a:pPr>
+              <a:spcAft>
+                <a:spcPts val="100"/>
+              </a:spcAft>
+            </a:pPr>
+            <a:r>
+              <a:rPr sz="950" b="1">
+                <a:solidFill>
+                  <a:srgbClr val="FFFFFF"/>
+                </a:solidFill>
+                <a:latin typeface="Segoe UI"/>
+              </a:rPr>
+              <a:t>· Microsoft 365 Copilot</a:t>
+            </a:r>
+          </a:p>
+          <a:p>
+            <a:pPr>
+              <a:spcAft>
+                <a:spcPts val="100"/>
+              </a:spcAft>
+            </a:pPr>
+            <a:r>
+              <a:rPr sz="950" b="1">
+                <a:solidFill>
+                  <a:srgbClr val="FFFFFF"/>
+                </a:solidFill>
+                <a:latin typeface="Segoe UI"/>
+              </a:rPr>
+              <a:t>· Claude Desktop, ChatGPT</a:t>
+            </a:r>
+          </a:p>
+          <a:p>
+            <a:pPr>
+              <a:spcAft>
+                <a:spcPts val="100"/>
+              </a:spcAft>
+            </a:pPr>
+            <a:r>
+              <a:rPr sz="950" b="1">
+                <a:solidFill>
+                  <a:srgbClr val="FFFFFF"/>
+                </a:solidFill>
+                <a:latin typeface="Segoe UI"/>
+              </a:rPr>
+              <a:t>· Foundry agents, your app</a:t>
+            </a:r>
+          </a:p>
+        </p:txBody>
+      </p:sp>
+      <p:sp>
+        <p:nvSpPr>
+          <p:cNvPr id="20" name="TextBox 19"/>
           <p:cNvSpPr txBox="1"/>
           <p:nvPr/>
         </p:nvSpPr>
         <p:spPr>
           <a:xfrm>
-            <a:off x="457200" y="3611880"/>
-            <a:ext cx="8229600" cy="731520"/>
+            <a:off x="3538728" y="2139696"/>
+            <a:ext cx="2103120" cy="1920240"/>
           </a:xfrm>
           <a:prstGeom prst="rect">
             <a:avLst/>
@@ -20044,14 +20241,288 @@
           <a:noFill/>
         </p:spPr>
         <p:txBody>
-          <a:bodyPr wrap="square" anchor="t" lIns="0" rIns="0" tIns="0" bIns="0">
+          <a:bodyPr wrap="square" lIns="0" rIns="0" tIns="0" bIns="0" anchor="t">
             <a:spAutoFit/>
           </a:bodyPr>
           <a:lstStyle/>
           <a:p>
-            <a:pPr algn="l"/>
-            <a:r>
-              <a:rPr sz="1300" b="0">
+            <a:pPr>
+              <a:spcAft>
+                <a:spcPts val="200"/>
+              </a:spcAft>
+            </a:pPr>
+            <a:r>
+              <a:rPr sz="900" b="1">
+                <a:solidFill>
+                  <a:srgbClr val="E1571E"/>
+                </a:solidFill>
+                <a:latin typeface="Segoe UI"/>
+              </a:rPr>
+              <a:t>CLIENT</a:t>
+            </a:r>
+          </a:p>
+          <a:p>
+            <a:pPr>
+              <a:spcAft>
+                <a:spcPts val="400"/>
+              </a:spcAft>
+            </a:pPr>
+            <a:r>
+              <a:rPr sz="1300" b="1">
+                <a:solidFill>
+                  <a:srgbClr val="23262E"/>
+                </a:solidFill>
+                <a:latin typeface="Segoe UI"/>
+              </a:rPr>
+              <a:t>The connector</a:t>
+            </a:r>
+          </a:p>
+          <a:p>
+            <a:pPr>
+              <a:spcAft>
+                <a:spcPts val="700"/>
+              </a:spcAft>
+            </a:pPr>
+            <a:r>
+              <a:rPr sz="950" b="0">
+                <a:solidFill>
+                  <a:srgbClr val="23262E"/>
+                </a:solidFill>
+                <a:latin typeface="Segoe UI"/>
+              </a:rPr>
+              <a:t>Lives inside the host, one per server. Speaks JSON-RPC over stdio or HTTP.</a:t>
+            </a:r>
+          </a:p>
+          <a:p>
+            <a:pPr>
+              <a:spcAft>
+                <a:spcPts val="200"/>
+              </a:spcAft>
+            </a:pPr>
+            <a:r>
+              <a:rPr sz="850" b="1">
+                <a:solidFill>
+                  <a:srgbClr val="E1571E"/>
+                </a:solidFill>
+                <a:latin typeface="Segoe UI"/>
+              </a:rPr>
+              <a:t>FOR EXAMPLE</a:t>
+            </a:r>
+          </a:p>
+          <a:p>
+            <a:pPr>
+              <a:spcAft>
+                <a:spcPts val="100"/>
+              </a:spcAft>
+            </a:pPr>
+            <a:r>
+              <a:rPr sz="950" b="1">
+                <a:solidFill>
+                  <a:srgbClr val="23262E"/>
+                </a:solidFill>
+                <a:latin typeface="Segoe UI"/>
+              </a:rPr>
+              <a:t>· GitHub Copilot (in VS Code)</a:t>
+            </a:r>
+          </a:p>
+          <a:p>
+            <a:pPr>
+              <a:spcAft>
+                <a:spcPts val="100"/>
+              </a:spcAft>
+            </a:pPr>
+            <a:r>
+              <a:rPr sz="950" b="1">
+                <a:solidFill>
+                  <a:srgbClr val="23262E"/>
+                </a:solidFill>
+                <a:latin typeface="Segoe UI"/>
+              </a:rPr>
+              <a:t>· Foundry's MCP tool</a:t>
+            </a:r>
+          </a:p>
+          <a:p>
+            <a:pPr>
+              <a:spcAft>
+                <a:spcPts val="100"/>
+              </a:spcAft>
+            </a:pPr>
+            <a:r>
+              <a:rPr sz="950" b="1">
+                <a:solidFill>
+                  <a:srgbClr val="23262E"/>
+                </a:solidFill>
+                <a:latin typeface="Segoe UI"/>
+              </a:rPr>
+              <a:t>· The MCP SDK in your app</a:t>
+            </a:r>
+          </a:p>
+        </p:txBody>
+      </p:sp>
+      <p:sp>
+        <p:nvSpPr>
+          <p:cNvPr id="21" name="TextBox 20"/>
+          <p:cNvSpPr txBox="1"/>
+          <p:nvPr/>
+        </p:nvSpPr>
+        <p:spPr>
+          <a:xfrm>
+            <a:off x="6464808" y="2139696"/>
+            <a:ext cx="2103120" cy="1920240"/>
+          </a:xfrm>
+          <a:prstGeom prst="rect">
+            <a:avLst/>
+          </a:prstGeom>
+          <a:noFill/>
+        </p:spPr>
+        <p:txBody>
+          <a:bodyPr wrap="square" lIns="0" rIns="0" tIns="0" bIns="0" anchor="t">
+            <a:spAutoFit/>
+          </a:bodyPr>
+          <a:lstStyle/>
+          <a:p>
+            <a:pPr>
+              <a:spcAft>
+                <a:spcPts val="200"/>
+              </a:spcAft>
+            </a:pPr>
+            <a:r>
+              <a:rPr sz="900" b="1">
+                <a:solidFill>
+                  <a:srgbClr val="FFFFFF"/>
+                </a:solidFill>
+                <a:latin typeface="Segoe UI"/>
+              </a:rPr>
+              <a:t>SERVER</a:t>
+            </a:r>
+          </a:p>
+          <a:p>
+            <a:pPr>
+              <a:spcAft>
+                <a:spcPts val="400"/>
+              </a:spcAft>
+            </a:pPr>
+            <a:r>
+              <a:rPr sz="1300" b="1">
+                <a:solidFill>
+                  <a:srgbClr val="FFFFFF"/>
+                </a:solidFill>
+                <a:latin typeface="Segoe UI"/>
+              </a:rPr>
+              <a:t>Your code, today</a:t>
+            </a:r>
+          </a:p>
+          <a:p>
+            <a:pPr>
+              <a:spcAft>
+                <a:spcPts val="700"/>
+              </a:spcAft>
+            </a:pPr>
+            <a:r>
+              <a:rPr sz="950" b="0">
+                <a:solidFill>
+                  <a:srgbClr val="FFFFFF"/>
+                </a:solidFill>
+                <a:latin typeface="Segoe UI"/>
+              </a:rPr>
+              <a:t>Tools (verbs) · Resources (nouns) · Prompts · MCP Apps (UI)</a:t>
+            </a:r>
+          </a:p>
+          <a:p>
+            <a:pPr>
+              <a:spcAft>
+                <a:spcPts val="200"/>
+              </a:spcAft>
+            </a:pPr>
+            <a:r>
+              <a:rPr sz="850" b="1">
+                <a:solidFill>
+                  <a:srgbClr val="FFFFFF"/>
+                </a:solidFill>
+                <a:latin typeface="Segoe UI"/>
+              </a:rPr>
+              <a:t>FOR EXAMPLE</a:t>
+            </a:r>
+          </a:p>
+          <a:p>
+            <a:pPr>
+              <a:spcAft>
+                <a:spcPts val="100"/>
+              </a:spcAft>
+            </a:pPr>
+            <a:r>
+              <a:rPr sz="950" b="1">
+                <a:solidFill>
+                  <a:srgbClr val="FFFFFF"/>
+                </a:solidFill>
+                <a:latin typeface="Segoe UI"/>
+              </a:rPr>
+              <a:t>· Today: 4 Azure Function apps</a:t>
+            </a:r>
+          </a:p>
+          <a:p>
+            <a:pPr>
+              <a:spcAft>
+                <a:spcPts val="100"/>
+              </a:spcAft>
+            </a:pPr>
+            <a:r>
+              <a:rPr sz="950" b="1">
+                <a:solidFill>
+                  <a:srgbClr val="FFFFFF"/>
+                </a:solidFill>
+                <a:latin typeface="Segoe UI"/>
+              </a:rPr>
+              <a:t>· GitHub, Azure, Playwright</a:t>
+            </a:r>
+          </a:p>
+          <a:p>
+            <a:pPr>
+              <a:spcAft>
+                <a:spcPts val="100"/>
+              </a:spcAft>
+            </a:pPr>
+            <a:r>
+              <a:rPr sz="950" b="1">
+                <a:solidFill>
+                  <a:srgbClr val="FFFFFF"/>
+                </a:solidFill>
+                <a:latin typeface="Segoe UI"/>
+              </a:rPr>
+              <a:t>· A Python file on a laptop</a:t>
+            </a:r>
+          </a:p>
+        </p:txBody>
+      </p:sp>
+      <p:sp>
+        <p:nvSpPr>
+          <p:cNvPr id="22" name="TextBox 21"/>
+          <p:cNvSpPr txBox="1"/>
+          <p:nvPr/>
+        </p:nvSpPr>
+        <p:spPr>
+          <a:xfrm>
+            <a:off x="457200" y="4242816"/>
+            <a:ext cx="8229600" cy="274320"/>
+          </a:xfrm>
+          <a:prstGeom prst="rect">
+            <a:avLst/>
+          </a:prstGeom>
+          <a:noFill/>
+        </p:spPr>
+        <p:txBody>
+          <a:bodyPr wrap="square" lIns="0" rIns="0" tIns="0" bIns="0" anchor="t">
+            <a:spAutoFit/>
+          </a:bodyPr>
+          <a:lstStyle/>
+          <a:p>
+            <a:pPr>
+              <a:spcAft>
+                <a:spcPts val="0"/>
+              </a:spcAft>
+            </a:pPr>
+            <a:r>
+              <a:rPr sz="1100" b="1">
                 <a:solidFill>
                   <a:srgbClr val="23262E"/>
                 </a:solidFill>

</xml_diff>